<commit_message>
word + ppt 完成
</commit_message>
<xml_diff>
--- a/112111102_吳映潔.pptx
+++ b/112111102_吳映潔.pptx
@@ -137,7 +137,7 @@
   <pc:docChgLst>
     <pc:chgData name="映潔 吳" userId="ce8478969c818b5d" providerId="LiveId" clId="{02718E11-8C50-4BF9-8911-C664F181BE0F}"/>
     <pc:docChg chg="undo custSel addSld delSld modSld sldOrd">
-      <pc:chgData name="映潔 吳" userId="ce8478969c818b5d" providerId="LiveId" clId="{02718E11-8C50-4BF9-8911-C664F181BE0F}" dt="2026-06-14T08:16:47.375" v="838" actId="1076"/>
+      <pc:chgData name="映潔 吳" userId="ce8478969c818b5d" providerId="LiveId" clId="{02718E11-8C50-4BF9-8911-C664F181BE0F}" dt="2026-06-14T08:34:15.932" v="840" actId="478"/>
       <pc:docMkLst>
         <pc:docMk/>
       </pc:docMkLst>
@@ -517,7 +517,7 @@
         </pc:spChg>
       </pc:sldChg>
       <pc:sldChg chg="addSp delSp modSp add mod">
-        <pc:chgData name="映潔 吳" userId="ce8478969c818b5d" providerId="LiveId" clId="{02718E11-8C50-4BF9-8911-C664F181BE0F}" dt="2026-06-14T03:10:46.990" v="768" actId="1076"/>
+        <pc:chgData name="映潔 吳" userId="ce8478969c818b5d" providerId="LiveId" clId="{02718E11-8C50-4BF9-8911-C664F181BE0F}" dt="2026-06-14T08:34:15.932" v="840" actId="478"/>
         <pc:sldMkLst>
           <pc:docMk/>
           <pc:sldMk cId="3276122178" sldId="263"/>
@@ -530,16 +530,16 @@
             <ac:spMk id="3" creationId="{73A2830E-9C06-05A3-686F-A1EF06210A69}"/>
           </ac:spMkLst>
         </pc:spChg>
-        <pc:spChg chg="add mod">
-          <ac:chgData name="映潔 吳" userId="ce8478969c818b5d" providerId="LiveId" clId="{02718E11-8C50-4BF9-8911-C664F181BE0F}" dt="2026-06-14T03:10:46.990" v="768" actId="1076"/>
+        <pc:spChg chg="add del mod">
+          <ac:chgData name="映潔 吳" userId="ce8478969c818b5d" providerId="LiveId" clId="{02718E11-8C50-4BF9-8911-C664F181BE0F}" dt="2026-06-14T08:34:15.932" v="840" actId="478"/>
           <ac:spMkLst>
             <pc:docMk/>
             <pc:sldMk cId="3276122178" sldId="263"/>
             <ac:spMk id="6" creationId="{8842C115-4F9A-66ED-F82C-EA9D9EE8DE41}"/>
           </ac:spMkLst>
         </pc:spChg>
-        <pc:picChg chg="add mod">
-          <ac:chgData name="映潔 吳" userId="ce8478969c818b5d" providerId="LiveId" clId="{02718E11-8C50-4BF9-8911-C664F181BE0F}" dt="2026-06-14T03:10:29.079" v="724" actId="1076"/>
+        <pc:picChg chg="add del mod">
+          <ac:chgData name="映潔 吳" userId="ce8478969c818b5d" providerId="LiveId" clId="{02718E11-8C50-4BF9-8911-C664F181BE0F}" dt="2026-06-14T08:34:12.715" v="839" actId="478"/>
           <ac:picMkLst>
             <pc:docMk/>
             <pc:sldMk cId="3276122178" sldId="263"/>
@@ -4461,95 +4461,6 @@
           </a:fontRef>
         </p:style>
       </p:cxnSp>
-      <p:pic>
-        <p:nvPicPr>
-          <p:cNvPr id="3" name="圖片 2">
-            <a:extLst>
-              <a:ext uri="{FF2B5EF4-FFF2-40B4-BE49-F238E27FC236}">
-                <a16:creationId xmlns:a16="http://schemas.microsoft.com/office/drawing/2014/main" id="{CEE97A7F-D95E-69D5-204B-EA2D559F0FFD}"/>
-              </a:ext>
-            </a:extLst>
-          </p:cNvPr>
-          <p:cNvPicPr>
-            <a:picLocks noChangeAspect="1"/>
-          </p:cNvPicPr>
-          <p:nvPr/>
-        </p:nvPicPr>
-        <p:blipFill>
-          <a:blip r:embed="rId2">
-            <a:extLst>
-              <a:ext uri="{28A0092B-C50C-407E-A947-70E740481C1C}">
-                <a14:useLocalDpi xmlns:a14="http://schemas.microsoft.com/office/drawing/2010/main" val="0"/>
-              </a:ext>
-            </a:extLst>
-          </a:blip>
-          <a:stretch>
-            <a:fillRect/>
-          </a:stretch>
-        </p:blipFill>
-        <p:spPr>
-          <a:xfrm>
-            <a:off x="1076067" y="2464908"/>
-            <a:ext cx="10039866" cy="3143412"/>
-          </a:xfrm>
-          <a:prstGeom prst="rect">
-            <a:avLst/>
-          </a:prstGeom>
-        </p:spPr>
-      </p:pic>
-      <p:sp>
-        <p:nvSpPr>
-          <p:cNvPr id="6" name="文字方塊 5">
-            <a:extLst>
-              <a:ext uri="{FF2B5EF4-FFF2-40B4-BE49-F238E27FC236}">
-                <a16:creationId xmlns:a16="http://schemas.microsoft.com/office/drawing/2014/main" id="{8842C115-4F9A-66ED-F82C-EA9D9EE8DE41}"/>
-              </a:ext>
-            </a:extLst>
-          </p:cNvPr>
-          <p:cNvSpPr txBox="1"/>
-          <p:nvPr/>
-        </p:nvSpPr>
-        <p:spPr>
-          <a:xfrm>
-            <a:off x="3048762" y="1442720"/>
-            <a:ext cx="6094476" cy="523220"/>
-          </a:xfrm>
-          <a:prstGeom prst="rect">
-            <a:avLst/>
-          </a:prstGeom>
-          <a:noFill/>
-        </p:spPr>
-        <p:txBody>
-          <a:bodyPr wrap="square">
-            <a:spAutoFit/>
-          </a:bodyPr>
-          <a:lstStyle/>
-          <a:p>
-            <a:pPr algn="ctr"/>
-            <a:r>
-              <a:rPr lang="zh-TW" altLang="en-US" sz="2800" b="1" dirty="0">
-                <a:solidFill>
-                  <a:schemeClr val="accent1">
-                    <a:lumMod val="50000"/>
-                  </a:schemeClr>
-                </a:solidFill>
-                <a:latin typeface="微軟正黑體" panose="020B0604030504040204" pitchFamily="34" charset="-120"/>
-                <a:ea typeface="微軟正黑體" panose="020B0604030504040204" pitchFamily="34" charset="-120"/>
-              </a:rPr>
-              <a:t>還要再改，不是最新版</a:t>
-            </a:r>
-            <a:endParaRPr lang="en-US" altLang="zh-TW" sz="2800" b="1" dirty="0">
-              <a:solidFill>
-                <a:schemeClr val="accent1">
-                  <a:lumMod val="50000"/>
-                </a:schemeClr>
-              </a:solidFill>
-              <a:latin typeface="微軟正黑體" panose="020B0604030504040204" pitchFamily="34" charset="-120"/>
-              <a:ea typeface="微軟正黑體" panose="020B0604030504040204" pitchFamily="34" charset="-120"/>
-            </a:endParaRPr>
-          </a:p>
-        </p:txBody>
-      </p:sp>
     </p:spTree>
     <p:extLst>
       <p:ext uri="{BB962C8B-B14F-4D97-AF65-F5344CB8AC3E}">

</xml_diff>